<commit_message>
Update presentation with voice recording'
</commit_message>
<xml_diff>
--- a/project/Project-Presentation.pptx
+++ b/project/Project-Presentation.pptx
@@ -3503,7 +3503,7 @@
   <dgm:whole/>
   <dgm:extLst>
     <a:ext uri="http://schemas.microsoft.com/office/drawing/2008/diagram">
-      <dsp:dataModelExt xmlns:dsp="http://schemas.microsoft.com/office/drawing/2008/diagram" relId="rId6" minVer="http://schemas.openxmlformats.org/drawingml/2006/diagram"/>
+      <dsp:dataModelExt xmlns:dsp="http://schemas.microsoft.com/office/drawing/2008/diagram" relId="rId8" minVer="http://schemas.openxmlformats.org/drawingml/2006/diagram"/>
     </a:ext>
   </dgm:extLst>
 </dgm:dataModel>
@@ -4083,13 +4083,13 @@
     <dgm:cxn modelId="{922BEB0C-A750-49B9-BC14-BBAC5A390074}" type="presOf" srcId="{CDEA14BB-631C-4C41-B1C2-CC65004BCF74}" destId="{3A5BC487-E01D-479D-9054-5ACF39FA7595}" srcOrd="0" destOrd="0" presId="urn:microsoft.com/office/officeart/2018/2/layout/IconVerticalSolidList"/>
     <dgm:cxn modelId="{971D1D14-1ECB-43E5-9700-6D7015EEA6F4}" type="presOf" srcId="{A5A10BF3-A296-4A82-B835-B287099B3278}" destId="{12F5BA97-75CC-475D-BD61-C0593D51DAB0}" srcOrd="0" destOrd="1" presId="urn:microsoft.com/office/officeart/2018/2/layout/IconVerticalSolidList"/>
     <dgm:cxn modelId="{37A1122D-A4B2-46DD-BE1C-FE9F491424BF}" type="presOf" srcId="{CBDB729D-B625-493D-846B-A73B69E6910E}" destId="{CC123ABB-BEA2-406D-BF37-C60EBF1FD53A}" srcOrd="0" destOrd="0" presId="urn:microsoft.com/office/officeart/2018/2/layout/IconVerticalSolidList"/>
+    <dgm:cxn modelId="{93294144-4FF0-4925-ABBC-A3C40B417F8F}" srcId="{F7AA10B3-CC61-4C27-A913-E6EC938D846B}" destId="{DD07AB76-08EF-49DF-BD00-7AD94B06AF8C}" srcOrd="1" destOrd="0" parTransId="{B4666544-016B-40AE-A239-AB6E32D0101E}" sibTransId="{526A8BD6-E609-4DD7-AE73-85A4ABD2844E}"/>
+    <dgm:cxn modelId="{1F6BCE45-6B7A-466F-BCE5-C67BE8192110}" type="presOf" srcId="{A71A2724-4D84-4A1A-88A7-9A3550062DE6}" destId="{55E58AE1-277F-4B20-94CF-74C5CEE11BB3}" srcOrd="0" destOrd="0" presId="urn:microsoft.com/office/officeart/2018/2/layout/IconVerticalSolidList"/>
+    <dgm:cxn modelId="{FF37A34B-4E5A-44E6-9331-DE2EF26D88B5}" srcId="{D402632D-0AC0-4151-AA28-88A232EC3517}" destId="{4519A8DD-58F7-4918-A4FC-88E675A79352}" srcOrd="1" destOrd="0" parTransId="{D44EE6E8-93DC-476D-855A-DFBC93CE0E49}" sibTransId="{0A16415A-AD48-4481-9B6A-B6F3CAB5AF27}"/>
     <dgm:cxn modelId="{48F91B5C-E10B-4268-83CE-CEA614F44BD9}" type="presOf" srcId="{DD07AB76-08EF-49DF-BD00-7AD94B06AF8C}" destId="{D7F83E8E-AB1E-41B7-B136-74922CE32EFA}" srcOrd="0" destOrd="0" presId="urn:microsoft.com/office/officeart/2018/2/layout/IconVerticalSolidList"/>
     <dgm:cxn modelId="{7E4C4961-1650-4181-A06D-8E03DBC5244D}" type="presOf" srcId="{31F9574E-C843-4D8F-B0C9-B270668C23CC}" destId="{12F5BA97-75CC-475D-BD61-C0593D51DAB0}" srcOrd="0" destOrd="0" presId="urn:microsoft.com/office/officeart/2018/2/layout/IconVerticalSolidList"/>
     <dgm:cxn modelId="{4C31FC63-B01B-4B08-A555-DE34D7A05C97}" srcId="{F7AA10B3-CC61-4C27-A913-E6EC938D846B}" destId="{A71A2724-4D84-4A1A-88A7-9A3550062DE6}" srcOrd="0" destOrd="0" parTransId="{23BDB464-AC53-4776-829B-DAEF48D995F6}" sibTransId="{5F9B104A-9586-4F97-83EC-715554F3B96D}"/>
-    <dgm:cxn modelId="{93294144-4FF0-4925-ABBC-A3C40B417F8F}" srcId="{F7AA10B3-CC61-4C27-A913-E6EC938D846B}" destId="{DD07AB76-08EF-49DF-BD00-7AD94B06AF8C}" srcOrd="1" destOrd="0" parTransId="{B4666544-016B-40AE-A239-AB6E32D0101E}" sibTransId="{526A8BD6-E609-4DD7-AE73-85A4ABD2844E}"/>
-    <dgm:cxn modelId="{1F6BCE45-6B7A-466F-BCE5-C67BE8192110}" type="presOf" srcId="{A71A2724-4D84-4A1A-88A7-9A3550062DE6}" destId="{55E58AE1-277F-4B20-94CF-74C5CEE11BB3}" srcOrd="0" destOrd="0" presId="urn:microsoft.com/office/officeart/2018/2/layout/IconVerticalSolidList"/>
     <dgm:cxn modelId="{EA4DC667-A739-4B14-BF93-EF71113B99B5}" srcId="{A71A2724-4D84-4A1A-88A7-9A3550062DE6}" destId="{31F9574E-C843-4D8F-B0C9-B270668C23CC}" srcOrd="0" destOrd="0" parTransId="{CA893D98-2CEB-497D-BE95-C208AAB06B5A}" sibTransId="{21D18BEC-4DBC-49DB-9B18-CE71F4F57370}"/>
-    <dgm:cxn modelId="{FF37A34B-4E5A-44E6-9331-DE2EF26D88B5}" srcId="{D402632D-0AC0-4151-AA28-88A232EC3517}" destId="{4519A8DD-58F7-4918-A4FC-88E675A79352}" srcOrd="1" destOrd="0" parTransId="{D44EE6E8-93DC-476D-855A-DFBC93CE0E49}" sibTransId="{0A16415A-AD48-4481-9B6A-B6F3CAB5AF27}"/>
     <dgm:cxn modelId="{F63CE76E-60E3-453B-8812-DE797FC3C97B}" type="presOf" srcId="{D3B323AA-CCD7-430D-BCC5-25A76190E1A5}" destId="{CC123ABB-BEA2-406D-BF37-C60EBF1FD53A}" srcOrd="0" destOrd="1" presId="urn:microsoft.com/office/officeart/2018/2/layout/IconVerticalSolidList"/>
     <dgm:cxn modelId="{DC1C859A-921C-4B46-A0B2-0E9A38D1AEC7}" type="presOf" srcId="{4519A8DD-58F7-4918-A4FC-88E675A79352}" destId="{3A5BC487-E01D-479D-9054-5ACF39FA7595}" srcOrd="0" destOrd="1" presId="urn:microsoft.com/office/officeart/2018/2/layout/IconVerticalSolidList"/>
     <dgm:cxn modelId="{E9DD69C1-6B76-4541-A268-E231D5EA5C09}" srcId="{D402632D-0AC0-4151-AA28-88A232EC3517}" destId="{CDEA14BB-631C-4C41-B1C2-CC65004BCF74}" srcOrd="0" destOrd="0" parTransId="{B5A3C456-50B2-4FB5-A7BE-B0C86D811592}" sibTransId="{612D9DE0-3B81-407A-8A0B-AF51BF9C46E2}"/>
@@ -4123,7 +4123,7 @@
   <dgm:whole/>
   <dgm:extLst>
     <a:ext uri="http://schemas.microsoft.com/office/drawing/2008/diagram">
-      <dsp:dataModelExt xmlns:dsp="http://schemas.microsoft.com/office/drawing/2008/diagram" relId="rId6" minVer="http://schemas.openxmlformats.org/drawingml/2006/diagram"/>
+      <dsp:dataModelExt xmlns:dsp="http://schemas.microsoft.com/office/drawing/2008/diagram" relId="rId8" minVer="http://schemas.openxmlformats.org/drawingml/2006/diagram"/>
     </a:ext>
   </dgm:extLst>
 </dgm:dataModel>
@@ -9748,7 +9748,7 @@
           <a:p>
             <a:fld id="{AB8591B1-6562-4512-8153-C86D5628630F}" type="datetimeFigureOut">
               <a:rPr lang="en-US" smtClean="0"/>
-              <a:t>06/03/2026</a:t>
+              <a:t>6/3/26</a:t>
             </a:fld>
             <a:endParaRPr lang="en-US"/>
           </a:p>
@@ -10373,7 +10373,7 @@
           <a:p>
             <a:fld id="{3C5E3940-567D-0E4A-B27A-538E5CA3F251}" type="datetimeFigureOut">
               <a:rPr lang="en-US" smtClean="0"/>
-              <a:t>06/03/2026</a:t>
+              <a:t>6/3/26</a:t>
             </a:fld>
             <a:endParaRPr lang="en-US"/>
           </a:p>
@@ -10571,7 +10571,7 @@
           <a:p>
             <a:fld id="{3C5E3940-567D-0E4A-B27A-538E5CA3F251}" type="datetimeFigureOut">
               <a:rPr lang="en-US" smtClean="0"/>
-              <a:t>06/03/2026</a:t>
+              <a:t>6/3/26</a:t>
             </a:fld>
             <a:endParaRPr lang="en-US"/>
           </a:p>
@@ -10779,7 +10779,7 @@
           <a:p>
             <a:fld id="{3C5E3940-567D-0E4A-B27A-538E5CA3F251}" type="datetimeFigureOut">
               <a:rPr lang="en-US" smtClean="0"/>
-              <a:t>06/03/2026</a:t>
+              <a:t>6/3/26</a:t>
             </a:fld>
             <a:endParaRPr lang="en-US"/>
           </a:p>
@@ -10977,7 +10977,7 @@
           <a:p>
             <a:fld id="{3C5E3940-567D-0E4A-B27A-538E5CA3F251}" type="datetimeFigureOut">
               <a:rPr lang="en-US" smtClean="0"/>
-              <a:t>06/03/2026</a:t>
+              <a:t>6/3/26</a:t>
             </a:fld>
             <a:endParaRPr lang="en-US"/>
           </a:p>
@@ -11252,7 +11252,7 @@
           <a:p>
             <a:fld id="{3C5E3940-567D-0E4A-B27A-538E5CA3F251}" type="datetimeFigureOut">
               <a:rPr lang="en-US" smtClean="0"/>
-              <a:t>06/03/2026</a:t>
+              <a:t>6/3/26</a:t>
             </a:fld>
             <a:endParaRPr lang="en-US"/>
           </a:p>
@@ -11517,7 +11517,7 @@
           <a:p>
             <a:fld id="{3C5E3940-567D-0E4A-B27A-538E5CA3F251}" type="datetimeFigureOut">
               <a:rPr lang="en-US" smtClean="0"/>
-              <a:t>06/03/2026</a:t>
+              <a:t>6/3/26</a:t>
             </a:fld>
             <a:endParaRPr lang="en-US"/>
           </a:p>
@@ -11929,7 +11929,7 @@
           <a:p>
             <a:fld id="{3C5E3940-567D-0E4A-B27A-538E5CA3F251}" type="datetimeFigureOut">
               <a:rPr lang="en-US" smtClean="0"/>
-              <a:t>06/03/2026</a:t>
+              <a:t>6/3/26</a:t>
             </a:fld>
             <a:endParaRPr lang="en-US"/>
           </a:p>
@@ -12070,7 +12070,7 @@
           <a:p>
             <a:fld id="{3C5E3940-567D-0E4A-B27A-538E5CA3F251}" type="datetimeFigureOut">
               <a:rPr lang="en-US" smtClean="0"/>
-              <a:t>06/03/2026</a:t>
+              <a:t>6/3/26</a:t>
             </a:fld>
             <a:endParaRPr lang="en-US"/>
           </a:p>
@@ -12183,7 +12183,7 @@
           <a:p>
             <a:fld id="{3C5E3940-567D-0E4A-B27A-538E5CA3F251}" type="datetimeFigureOut">
               <a:rPr lang="en-US" smtClean="0"/>
-              <a:t>06/03/2026</a:t>
+              <a:t>6/3/26</a:t>
             </a:fld>
             <a:endParaRPr lang="en-US"/>
           </a:p>
@@ -12494,7 +12494,7 @@
           <a:p>
             <a:fld id="{3C5E3940-567D-0E4A-B27A-538E5CA3F251}" type="datetimeFigureOut">
               <a:rPr lang="en-US" smtClean="0"/>
-              <a:t>06/03/2026</a:t>
+              <a:t>6/3/26</a:t>
             </a:fld>
             <a:endParaRPr lang="en-US"/>
           </a:p>
@@ -12782,7 +12782,7 @@
           <a:p>
             <a:fld id="{3C5E3940-567D-0E4A-B27A-538E5CA3F251}" type="datetimeFigureOut">
               <a:rPr lang="en-US" smtClean="0"/>
-              <a:t>06/03/2026</a:t>
+              <a:t>6/3/26</a:t>
             </a:fld>
             <a:endParaRPr lang="en-US"/>
           </a:p>
@@ -13023,7 +13023,7 @@
           <a:p>
             <a:fld id="{3C5E3940-567D-0E4A-B27A-538E5CA3F251}" type="datetimeFigureOut">
               <a:rPr lang="en-US" smtClean="0"/>
-              <a:t>06/03/2026</a:t>
+              <a:t>6/3/26</a:t>
             </a:fld>
             <a:endParaRPr lang="en-US"/>
           </a:p>
@@ -14243,7 +14243,7 @@
           <p:nvPr/>
         </p:nvPicPr>
         <p:blipFill>
-          <a:blip r:embed="rId2"/>
+          <a:blip r:embed="rId4"/>
           <a:stretch>
             <a:fillRect/>
           </a:stretch>
@@ -14252,6 +14252,43 @@
           <a:xfrm>
             <a:off x="6525453" y="1544873"/>
             <a:ext cx="5666547" cy="3768253"/>
+          </a:xfrm>
+          <a:prstGeom prst="rect">
+            <a:avLst/>
+          </a:prstGeom>
+        </p:spPr>
+      </p:pic>
+      <p:pic>
+        <p:nvPicPr>
+          <p:cNvPr id="11" name="Audio 10">
+            <a:extLst>
+              <a:ext uri="{FF2B5EF4-FFF2-40B4-BE49-F238E27FC236}">
+                <a16:creationId xmlns:a16="http://schemas.microsoft.com/office/drawing/2014/main" id="{1250E00B-4067-D990-7F90-638CF410CD38}"/>
+              </a:ext>
+            </a:extLst>
+          </p:cNvPr>
+          <p:cNvPicPr>
+            <a:picLocks noChangeAspect="1"/>
+          </p:cNvPicPr>
+          <p:nvPr>
+            <a:audioFile r:link="rId2"/>
+            <p:extLst>
+              <p:ext uri="{DAA4B4D4-6D71-4841-9C94-3DE7FCFB9230}">
+                <p14:media xmlns:p14="http://schemas.microsoft.com/office/powerpoint/2010/main" r:embed="rId1"/>
+              </p:ext>
+            </p:extLst>
+          </p:nvPr>
+        </p:nvPicPr>
+        <p:blipFill>
+          <a:blip r:embed="rId5"/>
+          <a:stretch>
+            <a:fillRect/>
+          </a:stretch>
+        </p:blipFill>
+        <p:spPr>
+          <a:xfrm>
+            <a:off x="11226800" y="5892800"/>
+            <a:ext cx="812800" cy="812800"/>
           </a:xfrm>
           <a:prstGeom prst="rect">
             <a:avLst/>
@@ -14268,6 +14305,101 @@
   <p:clrMapOvr>
     <a:masterClrMapping/>
   </p:clrMapOvr>
+  <mc:AlternateContent xmlns:mc="http://schemas.openxmlformats.org/markup-compatibility/2006">
+    <mc:Choice xmlns:p14="http://schemas.microsoft.com/office/powerpoint/2010/main" Requires="p14">
+      <p:transition spd="slow" p14:dur="2000" advTm="160064"/>
+    </mc:Choice>
+    <mc:Fallback>
+      <p:transition spd="slow" advTm="160064"/>
+    </mc:Fallback>
+  </mc:AlternateContent>
+  <p:timing>
+    <p:tnLst>
+      <p:par>
+        <p:cTn id="1" dur="indefinite" restart="never" nodeType="tmRoot">
+          <p:childTnLst>
+            <p:seq concurrent="1" nextAc="seek">
+              <p:cTn id="2" dur="indefinite" nodeType="mainSeq">
+                <p:childTnLst>
+                  <p:par>
+                    <p:cTn id="3" fill="hold">
+                      <p:stCondLst>
+                        <p:cond delay="indefinite"/>
+                        <p:cond evt="onBegin" delay="0">
+                          <p:tn val="2"/>
+                        </p:cond>
+                      </p:stCondLst>
+                      <p:childTnLst>
+                        <p:par>
+                          <p:cTn id="4" fill="hold">
+                            <p:stCondLst>
+                              <p:cond delay="0"/>
+                            </p:stCondLst>
+                            <p:childTnLst>
+                              <p:par>
+                                <p:cTn id="5" presetID="1" presetClass="mediacall" presetSubtype="0" fill="hold" nodeType="afterEffect">
+                                  <p:stCondLst>
+                                    <p:cond delay="0"/>
+                                  </p:stCondLst>
+                                  <p:childTnLst>
+                                    <p:cmd type="call" cmd="playFrom(0.0)">
+                                      <p:cBhvr>
+                                        <p:cTn id="6" dur="1" fill="hold"/>
+                                        <p:tgtEl>
+                                          <p:spTgt spid="11"/>
+                                        </p:tgtEl>
+                                      </p:cBhvr>
+                                    </p:cmd>
+                                  </p:childTnLst>
+                                </p:cTn>
+                              </p:par>
+                            </p:childTnLst>
+                          </p:cTn>
+                        </p:par>
+                      </p:childTnLst>
+                    </p:cTn>
+                  </p:par>
+                </p:childTnLst>
+              </p:cTn>
+              <p:prevCondLst>
+                <p:cond evt="onPrev" delay="0">
+                  <p:tgtEl>
+                    <p:sldTgt/>
+                  </p:tgtEl>
+                </p:cond>
+              </p:prevCondLst>
+              <p:nextCondLst>
+                <p:cond evt="onNext" delay="0">
+                  <p:tgtEl>
+                    <p:sldTgt/>
+                  </p:tgtEl>
+                </p:cond>
+              </p:nextCondLst>
+            </p:seq>
+            <p:audio isNarration="1">
+              <p:cMediaNode vol="80000" showWhenStopped="0">
+                <p:cTn id="7" fill="hold" display="0">
+                  <p:stCondLst>
+                    <p:cond delay="indefinite"/>
+                  </p:stCondLst>
+                  <p:endCondLst>
+                    <p:cond evt="onStopAudio" delay="0">
+                      <p:tgtEl>
+                        <p:sldTgt/>
+                      </p:tgtEl>
+                    </p:cond>
+                  </p:endCondLst>
+                </p:cTn>
+                <p:tgtEl>
+                  <p:spTgt spid="11"/>
+                </p:tgtEl>
+              </p:cMediaNode>
+            </p:audio>
+          </p:childTnLst>
+        </p:cTn>
+      </p:par>
+    </p:tnLst>
+  </p:timing>
 </p:sld>
 </file>
 
@@ -14536,10 +14668,47 @@
         </p:xfrm>
         <a:graphic>
           <a:graphicData uri="http://schemas.openxmlformats.org/drawingml/2006/diagram">
-            <dgm:relIds xmlns:dgm="http://schemas.openxmlformats.org/drawingml/2006/diagram" xmlns:r="http://schemas.openxmlformats.org/officeDocument/2006/relationships" r:dm="rId2" r:lo="rId3" r:qs="rId4" r:cs="rId5"/>
+            <dgm:relIds xmlns:dgm="http://schemas.openxmlformats.org/drawingml/2006/diagram" xmlns:r="http://schemas.openxmlformats.org/officeDocument/2006/relationships" r:dm="rId4" r:lo="rId5" r:qs="rId6" r:cs="rId7"/>
           </a:graphicData>
         </a:graphic>
       </p:graphicFrame>
+      <p:pic>
+        <p:nvPicPr>
+          <p:cNvPr id="14" name="Audio 13">
+            <a:extLst>
+              <a:ext uri="{FF2B5EF4-FFF2-40B4-BE49-F238E27FC236}">
+                <a16:creationId xmlns:a16="http://schemas.microsoft.com/office/drawing/2014/main" id="{20915839-02E0-F93F-D781-C003AF1F6075}"/>
+              </a:ext>
+            </a:extLst>
+          </p:cNvPr>
+          <p:cNvPicPr>
+            <a:picLocks noChangeAspect="1"/>
+          </p:cNvPicPr>
+          <p:nvPr>
+            <a:audioFile r:link="rId2"/>
+            <p:extLst>
+              <p:ext uri="{DAA4B4D4-6D71-4841-9C94-3DE7FCFB9230}">
+                <p14:media xmlns:p14="http://schemas.microsoft.com/office/powerpoint/2010/main" r:embed="rId1"/>
+              </p:ext>
+            </p:extLst>
+          </p:nvPr>
+        </p:nvPicPr>
+        <p:blipFill>
+          <a:blip r:embed="rId9"/>
+          <a:stretch>
+            <a:fillRect/>
+          </a:stretch>
+        </p:blipFill>
+        <p:spPr>
+          <a:xfrm>
+            <a:off x="11226800" y="5892800"/>
+            <a:ext cx="812800" cy="812800"/>
+          </a:xfrm>
+          <a:prstGeom prst="rect">
+            <a:avLst/>
+          </a:prstGeom>
+        </p:spPr>
+      </p:pic>
     </p:spTree>
     <p:extLst>
       <p:ext uri="{BB962C8B-B14F-4D97-AF65-F5344CB8AC3E}">
@@ -14550,6 +14719,101 @@
   <p:clrMapOvr>
     <a:masterClrMapping/>
   </p:clrMapOvr>
+  <mc:AlternateContent xmlns:mc="http://schemas.openxmlformats.org/markup-compatibility/2006">
+    <mc:Choice xmlns:p14="http://schemas.microsoft.com/office/powerpoint/2010/main" Requires="p14">
+      <p:transition spd="slow" p14:dur="2000" advTm="54881"/>
+    </mc:Choice>
+    <mc:Fallback>
+      <p:transition spd="slow" advTm="54881"/>
+    </mc:Fallback>
+  </mc:AlternateContent>
+  <p:timing>
+    <p:tnLst>
+      <p:par>
+        <p:cTn id="1" dur="indefinite" restart="never" nodeType="tmRoot">
+          <p:childTnLst>
+            <p:seq concurrent="1" nextAc="seek">
+              <p:cTn id="2" dur="indefinite" nodeType="mainSeq">
+                <p:childTnLst>
+                  <p:par>
+                    <p:cTn id="3" fill="hold">
+                      <p:stCondLst>
+                        <p:cond delay="indefinite"/>
+                        <p:cond evt="onBegin" delay="0">
+                          <p:tn val="2"/>
+                        </p:cond>
+                      </p:stCondLst>
+                      <p:childTnLst>
+                        <p:par>
+                          <p:cTn id="4" fill="hold">
+                            <p:stCondLst>
+                              <p:cond delay="0"/>
+                            </p:stCondLst>
+                            <p:childTnLst>
+                              <p:par>
+                                <p:cTn id="5" presetID="1" presetClass="mediacall" presetSubtype="0" fill="hold" nodeType="afterEffect">
+                                  <p:stCondLst>
+                                    <p:cond delay="0"/>
+                                  </p:stCondLst>
+                                  <p:childTnLst>
+                                    <p:cmd type="call" cmd="playFrom(0.0)">
+                                      <p:cBhvr>
+                                        <p:cTn id="6" dur="1" fill="hold"/>
+                                        <p:tgtEl>
+                                          <p:spTgt spid="14"/>
+                                        </p:tgtEl>
+                                      </p:cBhvr>
+                                    </p:cmd>
+                                  </p:childTnLst>
+                                </p:cTn>
+                              </p:par>
+                            </p:childTnLst>
+                          </p:cTn>
+                        </p:par>
+                      </p:childTnLst>
+                    </p:cTn>
+                  </p:par>
+                </p:childTnLst>
+              </p:cTn>
+              <p:prevCondLst>
+                <p:cond evt="onPrev" delay="0">
+                  <p:tgtEl>
+                    <p:sldTgt/>
+                  </p:tgtEl>
+                </p:cond>
+              </p:prevCondLst>
+              <p:nextCondLst>
+                <p:cond evt="onNext" delay="0">
+                  <p:tgtEl>
+                    <p:sldTgt/>
+                  </p:tgtEl>
+                </p:cond>
+              </p:nextCondLst>
+            </p:seq>
+            <p:audio isNarration="1">
+              <p:cMediaNode vol="80000" showWhenStopped="0">
+                <p:cTn id="7" fill="hold" display="0">
+                  <p:stCondLst>
+                    <p:cond delay="indefinite"/>
+                  </p:stCondLst>
+                  <p:endCondLst>
+                    <p:cond evt="onStopAudio" delay="0">
+                      <p:tgtEl>
+                        <p:sldTgt/>
+                      </p:tgtEl>
+                    </p:cond>
+                  </p:endCondLst>
+                </p:cTn>
+                <p:tgtEl>
+                  <p:spTgt spid="14"/>
+                </p:tgtEl>
+              </p:cMediaNode>
+            </p:audio>
+          </p:childTnLst>
+        </p:cTn>
+      </p:par>
+    </p:tnLst>
+  </p:timing>
 </p:sld>
 </file>
 
@@ -14796,6 +15060,43 @@
           </a:fontRef>
         </p:style>
       </p:cxnSp>
+      <p:pic>
+        <p:nvPicPr>
+          <p:cNvPr id="6" name="Audio 5">
+            <a:extLst>
+              <a:ext uri="{FF2B5EF4-FFF2-40B4-BE49-F238E27FC236}">
+                <a16:creationId xmlns:a16="http://schemas.microsoft.com/office/drawing/2014/main" id="{11634080-A720-622C-8E7B-D2C740C11CBE}"/>
+              </a:ext>
+            </a:extLst>
+          </p:cNvPr>
+          <p:cNvPicPr>
+            <a:picLocks noChangeAspect="1"/>
+          </p:cNvPicPr>
+          <p:nvPr>
+            <a:audioFile r:link="rId2"/>
+            <p:extLst>
+              <p:ext uri="{DAA4B4D4-6D71-4841-9C94-3DE7FCFB9230}">
+                <p14:media xmlns:p14="http://schemas.microsoft.com/office/powerpoint/2010/main" r:embed="rId1"/>
+              </p:ext>
+            </p:extLst>
+          </p:nvPr>
+        </p:nvPicPr>
+        <p:blipFill>
+          <a:blip r:embed="rId4"/>
+          <a:stretch>
+            <a:fillRect/>
+          </a:stretch>
+        </p:blipFill>
+        <p:spPr>
+          <a:xfrm>
+            <a:off x="11226800" y="5892800"/>
+            <a:ext cx="812800" cy="812800"/>
+          </a:xfrm>
+          <a:prstGeom prst="rect">
+            <a:avLst/>
+          </a:prstGeom>
+        </p:spPr>
+      </p:pic>
     </p:spTree>
     <p:extLst>
       <p:ext uri="{BB962C8B-B14F-4D97-AF65-F5344CB8AC3E}">
@@ -14806,6 +15107,101 @@
   <p:clrMapOvr>
     <a:masterClrMapping/>
   </p:clrMapOvr>
+  <mc:AlternateContent xmlns:mc="http://schemas.openxmlformats.org/markup-compatibility/2006">
+    <mc:Choice xmlns:p14="http://schemas.microsoft.com/office/powerpoint/2010/main" Requires="p14">
+      <p:transition spd="slow" p14:dur="2000" advTm="47168"/>
+    </mc:Choice>
+    <mc:Fallback>
+      <p:transition spd="slow" advTm="47168"/>
+    </mc:Fallback>
+  </mc:AlternateContent>
+  <p:timing>
+    <p:tnLst>
+      <p:par>
+        <p:cTn id="1" dur="indefinite" restart="never" nodeType="tmRoot">
+          <p:childTnLst>
+            <p:seq concurrent="1" nextAc="seek">
+              <p:cTn id="2" dur="indefinite" nodeType="mainSeq">
+                <p:childTnLst>
+                  <p:par>
+                    <p:cTn id="3" fill="hold">
+                      <p:stCondLst>
+                        <p:cond delay="indefinite"/>
+                        <p:cond evt="onBegin" delay="0">
+                          <p:tn val="2"/>
+                        </p:cond>
+                      </p:stCondLst>
+                      <p:childTnLst>
+                        <p:par>
+                          <p:cTn id="4" fill="hold">
+                            <p:stCondLst>
+                              <p:cond delay="0"/>
+                            </p:stCondLst>
+                            <p:childTnLst>
+                              <p:par>
+                                <p:cTn id="5" presetID="1" presetClass="mediacall" presetSubtype="0" fill="hold" nodeType="afterEffect">
+                                  <p:stCondLst>
+                                    <p:cond delay="0"/>
+                                  </p:stCondLst>
+                                  <p:childTnLst>
+                                    <p:cmd type="call" cmd="playFrom(0.0)">
+                                      <p:cBhvr>
+                                        <p:cTn id="6" dur="1" fill="hold"/>
+                                        <p:tgtEl>
+                                          <p:spTgt spid="6"/>
+                                        </p:tgtEl>
+                                      </p:cBhvr>
+                                    </p:cmd>
+                                  </p:childTnLst>
+                                </p:cTn>
+                              </p:par>
+                            </p:childTnLst>
+                          </p:cTn>
+                        </p:par>
+                      </p:childTnLst>
+                    </p:cTn>
+                  </p:par>
+                </p:childTnLst>
+              </p:cTn>
+              <p:prevCondLst>
+                <p:cond evt="onPrev" delay="0">
+                  <p:tgtEl>
+                    <p:sldTgt/>
+                  </p:tgtEl>
+                </p:cond>
+              </p:prevCondLst>
+              <p:nextCondLst>
+                <p:cond evt="onNext" delay="0">
+                  <p:tgtEl>
+                    <p:sldTgt/>
+                  </p:tgtEl>
+                </p:cond>
+              </p:nextCondLst>
+            </p:seq>
+            <p:audio isNarration="1">
+              <p:cMediaNode vol="80000" showWhenStopped="0">
+                <p:cTn id="7" fill="hold" display="0">
+                  <p:stCondLst>
+                    <p:cond delay="indefinite"/>
+                  </p:stCondLst>
+                  <p:endCondLst>
+                    <p:cond evt="onStopAudio" delay="0">
+                      <p:tgtEl>
+                        <p:sldTgt/>
+                      </p:tgtEl>
+                    </p:cond>
+                  </p:endCondLst>
+                </p:cTn>
+                <p:tgtEl>
+                  <p:spTgt spid="6"/>
+                </p:tgtEl>
+              </p:cMediaNode>
+            </p:audio>
+          </p:childTnLst>
+        </p:cTn>
+      </p:par>
+    </p:tnLst>
+  </p:timing>
 </p:sld>
 </file>
 
@@ -20095,10 +20491,47 @@
         </p:xfrm>
         <a:graphic>
           <a:graphicData uri="http://schemas.openxmlformats.org/drawingml/2006/diagram">
-            <dgm:relIds xmlns:dgm="http://schemas.openxmlformats.org/drawingml/2006/diagram" xmlns:r="http://schemas.openxmlformats.org/officeDocument/2006/relationships" r:dm="rId2" r:lo="rId3" r:qs="rId4" r:cs="rId5"/>
+            <dgm:relIds xmlns:dgm="http://schemas.openxmlformats.org/drawingml/2006/diagram" xmlns:r="http://schemas.openxmlformats.org/officeDocument/2006/relationships" r:dm="rId4" r:lo="rId5" r:qs="rId6" r:cs="rId7"/>
           </a:graphicData>
         </a:graphic>
       </p:graphicFrame>
+      <p:pic>
+        <p:nvPicPr>
+          <p:cNvPr id="48" name="Audio 47">
+            <a:extLst>
+              <a:ext uri="{FF2B5EF4-FFF2-40B4-BE49-F238E27FC236}">
+                <a16:creationId xmlns:a16="http://schemas.microsoft.com/office/drawing/2014/main" id="{D61F1B5D-A794-B5B1-9972-FD9FBAE891A2}"/>
+              </a:ext>
+            </a:extLst>
+          </p:cNvPr>
+          <p:cNvPicPr>
+            <a:picLocks noChangeAspect="1"/>
+          </p:cNvPicPr>
+          <p:nvPr>
+            <a:audioFile r:link="rId2"/>
+            <p:extLst>
+              <p:ext uri="{DAA4B4D4-6D71-4841-9C94-3DE7FCFB9230}">
+                <p14:media xmlns:p14="http://schemas.microsoft.com/office/powerpoint/2010/main" r:embed="rId1"/>
+              </p:ext>
+            </p:extLst>
+          </p:nvPr>
+        </p:nvPicPr>
+        <p:blipFill>
+          <a:blip r:embed="rId9"/>
+          <a:stretch>
+            <a:fillRect/>
+          </a:stretch>
+        </p:blipFill>
+        <p:spPr>
+          <a:xfrm>
+            <a:off x="11226800" y="5892800"/>
+            <a:ext cx="812800" cy="812800"/>
+          </a:xfrm>
+          <a:prstGeom prst="rect">
+            <a:avLst/>
+          </a:prstGeom>
+        </p:spPr>
+      </p:pic>
     </p:spTree>
     <p:extLst>
       <p:ext uri="{BB962C8B-B14F-4D97-AF65-F5344CB8AC3E}">
@@ -20109,6 +20542,101 @@
   <p:clrMapOvr>
     <a:masterClrMapping/>
   </p:clrMapOvr>
+  <mc:AlternateContent xmlns:mc="http://schemas.openxmlformats.org/markup-compatibility/2006">
+    <mc:Choice xmlns:p14="http://schemas.microsoft.com/office/powerpoint/2010/main" Requires="p14">
+      <p:transition spd="slow" p14:dur="2000" advTm="87393"/>
+    </mc:Choice>
+    <mc:Fallback>
+      <p:transition spd="slow" advTm="87393"/>
+    </mc:Fallback>
+  </mc:AlternateContent>
+  <p:timing>
+    <p:tnLst>
+      <p:par>
+        <p:cTn id="1" dur="indefinite" restart="never" nodeType="tmRoot">
+          <p:childTnLst>
+            <p:seq concurrent="1" nextAc="seek">
+              <p:cTn id="2" dur="indefinite" nodeType="mainSeq">
+                <p:childTnLst>
+                  <p:par>
+                    <p:cTn id="3" fill="hold">
+                      <p:stCondLst>
+                        <p:cond delay="indefinite"/>
+                        <p:cond evt="onBegin" delay="0">
+                          <p:tn val="2"/>
+                        </p:cond>
+                      </p:stCondLst>
+                      <p:childTnLst>
+                        <p:par>
+                          <p:cTn id="4" fill="hold">
+                            <p:stCondLst>
+                              <p:cond delay="0"/>
+                            </p:stCondLst>
+                            <p:childTnLst>
+                              <p:par>
+                                <p:cTn id="5" presetID="1" presetClass="mediacall" presetSubtype="0" fill="hold" nodeType="afterEffect">
+                                  <p:stCondLst>
+                                    <p:cond delay="0"/>
+                                  </p:stCondLst>
+                                  <p:childTnLst>
+                                    <p:cmd type="call" cmd="playFrom(0.0)">
+                                      <p:cBhvr>
+                                        <p:cTn id="6" dur="1" fill="hold"/>
+                                        <p:tgtEl>
+                                          <p:spTgt spid="48"/>
+                                        </p:tgtEl>
+                                      </p:cBhvr>
+                                    </p:cmd>
+                                  </p:childTnLst>
+                                </p:cTn>
+                              </p:par>
+                            </p:childTnLst>
+                          </p:cTn>
+                        </p:par>
+                      </p:childTnLst>
+                    </p:cTn>
+                  </p:par>
+                </p:childTnLst>
+              </p:cTn>
+              <p:prevCondLst>
+                <p:cond evt="onPrev" delay="0">
+                  <p:tgtEl>
+                    <p:sldTgt/>
+                  </p:tgtEl>
+                </p:cond>
+              </p:prevCondLst>
+              <p:nextCondLst>
+                <p:cond evt="onNext" delay="0">
+                  <p:tgtEl>
+                    <p:sldTgt/>
+                  </p:tgtEl>
+                </p:cond>
+              </p:nextCondLst>
+            </p:seq>
+            <p:audio isNarration="1">
+              <p:cMediaNode vol="80000" showWhenStopped="0">
+                <p:cTn id="7" fill="hold" display="0">
+                  <p:stCondLst>
+                    <p:cond delay="indefinite"/>
+                  </p:stCondLst>
+                  <p:endCondLst>
+                    <p:cond evt="onStopAudio" delay="0">
+                      <p:tgtEl>
+                        <p:sldTgt/>
+                      </p:tgtEl>
+                    </p:cond>
+                  </p:endCondLst>
+                </p:cTn>
+                <p:tgtEl>
+                  <p:spTgt spid="48"/>
+                </p:tgtEl>
+              </p:cMediaNode>
+            </p:audio>
+          </p:childTnLst>
+        </p:cTn>
+      </p:par>
+    </p:tnLst>
+  </p:timing>
 </p:sld>
 </file>
 
@@ -20752,6 +21280,12 @@
 </file>
 
 <file path=customXml/item2.xml><?xml version="1.0" encoding="utf-8"?>
+<p:properties xmlns:p="http://schemas.microsoft.com/office/2006/metadata/properties" xmlns:xsi="http://www.w3.org/2001/XMLSchema-instance" xmlns:pc="http://schemas.microsoft.com/office/infopath/2007/PartnerControls">
+  <documentManagement/>
+</p:properties>
+</file>
+
+<file path=customXml/item3.xml><?xml version="1.0" encoding="utf-8"?>
 <ct:contentTypeSchema xmlns:ct="http://schemas.microsoft.com/office/2006/metadata/contentType" xmlns:ma="http://schemas.microsoft.com/office/2006/metadata/properties/metaAttributes" ct:_="" ma:_="" ma:contentTypeName="Document" ma:contentTypeID="0x0101001977F4A02A317C42B024828369745087" ma:contentTypeVersion="1" ma:contentTypeDescription="Create a new document." ma:contentTypeScope="" ma:versionID="c4dd34d2f253302d809d0638651758a5">
   <xsd:schema xmlns:xsd="http://www.w3.org/2001/XMLSchema" xmlns:xs="http://www.w3.org/2001/XMLSchema" xmlns:p="http://schemas.microsoft.com/office/2006/metadata/properties" xmlns:ns3="19149eaa-78a7-4c13-bd81-fa7ad81bba69" targetNamespace="http://schemas.microsoft.com/office/2006/metadata/properties" ma:root="true" ma:fieldsID="b1f8b89e39192d90fca2f9d2c18adb86" ns3:_="">
     <xsd:import namespace="19149eaa-78a7-4c13-bd81-fa7ad81bba69"/>
@@ -20877,12 +21411,6 @@
 </ct:contentTypeSchema>
 </file>
 
-<file path=customXml/item3.xml><?xml version="1.0" encoding="utf-8"?>
-<p:properties xmlns:p="http://schemas.microsoft.com/office/2006/metadata/properties" xmlns:xsi="http://www.w3.org/2001/XMLSchema-instance" xmlns:pc="http://schemas.microsoft.com/office/infopath/2007/PartnerControls">
-  <documentManagement/>
-</p:properties>
-</file>
-
 <file path=customXml/itemProps1.xml><?xml version="1.0" encoding="utf-8"?>
 <ds:datastoreItem xmlns:ds="http://schemas.openxmlformats.org/officeDocument/2006/customXml" ds:itemID="{D43A19D8-B8BC-41EF-B29F-C5418F08156C}">
   <ds:schemaRefs>
@@ -20892,6 +21420,22 @@
 </file>
 
 <file path=customXml/itemProps2.xml><?xml version="1.0" encoding="utf-8"?>
+<ds:datastoreItem xmlns:ds="http://schemas.openxmlformats.org/officeDocument/2006/customXml" ds:itemID="{4022A0F6-B6FD-4379-AC99-1FBF977FED2B}">
+  <ds:schemaRefs>
+    <ds:schemaRef ds:uri="http://purl.org/dc/elements/1.1/"/>
+    <ds:schemaRef ds:uri="http://schemas.microsoft.com/office/2006/metadata/properties"/>
+    <ds:schemaRef ds:uri="http://purl.org/dc/dcmitype/"/>
+    <ds:schemaRef ds:uri="http://purl.org/dc/terms/"/>
+    <ds:schemaRef ds:uri="http://www.w3.org/XML/1998/namespace"/>
+    <ds:schemaRef ds:uri="http://schemas.microsoft.com/office/2006/documentManagement/types"/>
+    <ds:schemaRef ds:uri="http://schemas.microsoft.com/office/infopath/2007/PartnerControls"/>
+    <ds:schemaRef ds:uri="http://schemas.openxmlformats.org/package/2006/metadata/core-properties"/>
+    <ds:schemaRef ds:uri="19149eaa-78a7-4c13-bd81-fa7ad81bba69"/>
+  </ds:schemaRefs>
+</ds:datastoreItem>
+</file>
+
+<file path=customXml/itemProps3.xml><?xml version="1.0" encoding="utf-8"?>
 <ds:datastoreItem xmlns:ds="http://schemas.openxmlformats.org/officeDocument/2006/customXml" ds:itemID="{0D815BB1-DFC0-4E1E-9A9F-1CA2AA9A35AB}">
   <ds:schemaRefs>
     <ds:schemaRef ds:uri="http://schemas.microsoft.com/office/2006/metadata/contentType"/>
@@ -20907,20 +21451,4 @@
     <ds:schemaRef ds:uri="http://schemas.microsoft.com/internal/obd"/>
   </ds:schemaRefs>
 </ds:datastoreItem>
-</file>
-
-<file path=customXml/itemProps3.xml><?xml version="1.0" encoding="utf-8"?>
-<ds:datastoreItem xmlns:ds="http://schemas.openxmlformats.org/officeDocument/2006/customXml" ds:itemID="{4022A0F6-B6FD-4379-AC99-1FBF977FED2B}">
-  <ds:schemaRefs>
-    <ds:schemaRef ds:uri="http://purl.org/dc/elements/1.1/"/>
-    <ds:schemaRef ds:uri="http://schemas.microsoft.com/office/2006/metadata/properties"/>
-    <ds:schemaRef ds:uri="http://purl.org/dc/dcmitype/"/>
-    <ds:schemaRef ds:uri="http://purl.org/dc/terms/"/>
-    <ds:schemaRef ds:uri="http://www.w3.org/XML/1998/namespace"/>
-    <ds:schemaRef ds:uri="http://schemas.microsoft.com/office/2006/documentManagement/types"/>
-    <ds:schemaRef ds:uri="http://schemas.microsoft.com/office/infopath/2007/PartnerControls"/>
-    <ds:schemaRef ds:uri="http://schemas.openxmlformats.org/package/2006/metadata/core-properties"/>
-    <ds:schemaRef ds:uri="19149eaa-78a7-4c13-bd81-fa7ad81bba69"/>
-  </ds:schemaRefs>
-</ds:datastoreItem>
 </file>
</xml_diff>

<commit_message>
Add 2024 and 2025 to dataset and output to csv
</commit_message>
<xml_diff>
--- a/project/Project-Presentation.pptx
+++ b/project/Project-Presentation.pptx
@@ -130,7 +130,6 @@
 <p1510:revInfo xmlns:a="http://schemas.openxmlformats.org/drawingml/2006/main" xmlns:r="http://schemas.openxmlformats.org/officeDocument/2006/relationships" xmlns:p1510="http://schemas.microsoft.com/office/powerpoint/2015/10/main">
   <p1510:revLst>
     <p1510:client id="{925A600D-6620-44DA-99F8-5D643D911C76}" v="1" dt="2026-06-03T21:58:28.913"/>
-    <p1510:client id="{C143A0DF-E1C0-4B03-8E4A-64E8E40E2A92}" v="17" dt="2026-06-03T01:47:06.035"/>
   </p1510:revLst>
 </p1510:revInfo>
 </file>
@@ -140,18 +139,18 @@
   <pc:docChgLst>
     <pc:chgData name="Nguyen,Quang" userId="23891ed8-be2c-452b-90d3-fcb364b9bbff" providerId="ADAL" clId="{34BD0BAB-0731-4425-A030-A15B82932F5E}"/>
     <pc:docChg chg="modSld">
-      <pc:chgData name="Nguyen,Quang" userId="23891ed8-be2c-452b-90d3-fcb364b9bbff" providerId="ADAL" clId="{34BD0BAB-0731-4425-A030-A15B82932F5E}" dt="2026-06-03T23:18:11.818" v="43" actId="20577"/>
+      <pc:chgData name="Nguyen,Quang" userId="23891ed8-be2c-452b-90d3-fcb364b9bbff" providerId="ADAL" clId="{34BD0BAB-0731-4425-A030-A15B82932F5E}" dt="2026-06-04T17:00:26.323" v="37" actId="20577"/>
       <pc:docMkLst>
         <pc:docMk/>
       </pc:docMkLst>
       <pc:sldChg chg="modSp mod modNotesTx">
-        <pc:chgData name="Nguyen,Quang" userId="23891ed8-be2c-452b-90d3-fcb364b9bbff" providerId="ADAL" clId="{34BD0BAB-0731-4425-A030-A15B82932F5E}" dt="2026-06-03T23:18:11.818" v="43" actId="20577"/>
+        <pc:chgData name="Nguyen,Quang" userId="23891ed8-be2c-452b-90d3-fcb364b9bbff" providerId="ADAL" clId="{34BD0BAB-0731-4425-A030-A15B82932F5E}" dt="2026-06-04T17:00:26.323" v="37" actId="20577"/>
         <pc:sldMkLst>
           <pc:docMk/>
           <pc:sldMk cId="3298431866" sldId="258"/>
         </pc:sldMkLst>
         <pc:spChg chg="mod">
-          <ac:chgData name="Nguyen,Quang" userId="23891ed8-be2c-452b-90d3-fcb364b9bbff" providerId="ADAL" clId="{34BD0BAB-0731-4425-A030-A15B82932F5E}" dt="2026-06-03T23:18:11.818" v="43" actId="20577"/>
+          <ac:chgData name="Nguyen,Quang" userId="23891ed8-be2c-452b-90d3-fcb364b9bbff" providerId="ADAL" clId="{34BD0BAB-0731-4425-A030-A15B82932F5E}" dt="2026-06-04T17:00:26.323" v="37" actId="20577"/>
           <ac:spMkLst>
             <pc:docMk/>
             <pc:sldMk cId="3298431866" sldId="258"/>
@@ -3503,7 +3502,7 @@
   <dgm:whole/>
   <dgm:extLst>
     <a:ext uri="http://schemas.microsoft.com/office/drawing/2008/diagram">
-      <dsp:dataModelExt xmlns:dsp="http://schemas.microsoft.com/office/drawing/2008/diagram" relId="rId6" minVer="http://schemas.openxmlformats.org/drawingml/2006/diagram"/>
+      <dsp:dataModelExt xmlns:dsp="http://schemas.microsoft.com/office/drawing/2008/diagram" relId="rId8" minVer="http://schemas.openxmlformats.org/drawingml/2006/diagram"/>
     </a:ext>
   </dgm:extLst>
 </dgm:dataModel>
@@ -4123,7 +4122,7 @@
   <dgm:whole/>
   <dgm:extLst>
     <a:ext uri="http://schemas.microsoft.com/office/drawing/2008/diagram">
-      <dsp:dataModelExt xmlns:dsp="http://schemas.microsoft.com/office/drawing/2008/diagram" relId="rId6" minVer="http://schemas.openxmlformats.org/drawingml/2006/diagram"/>
+      <dsp:dataModelExt xmlns:dsp="http://schemas.microsoft.com/office/drawing/2008/diagram" relId="rId8" minVer="http://schemas.openxmlformats.org/drawingml/2006/diagram"/>
     </a:ext>
   </dgm:extLst>
 </dgm:dataModel>
@@ -9748,7 +9747,7 @@
           <a:p>
             <a:fld id="{AB8591B1-6562-4512-8153-C86D5628630F}" type="datetimeFigureOut">
               <a:rPr lang="en-US" smtClean="0"/>
-              <a:t>06/03/2026</a:t>
+              <a:t>06/04/2026</a:t>
             </a:fld>
             <a:endParaRPr lang="en-US"/>
           </a:p>
@@ -10373,7 +10372,7 @@
           <a:p>
             <a:fld id="{3C5E3940-567D-0E4A-B27A-538E5CA3F251}" type="datetimeFigureOut">
               <a:rPr lang="en-US" smtClean="0"/>
-              <a:t>06/03/2026</a:t>
+              <a:t>06/04/2026</a:t>
             </a:fld>
             <a:endParaRPr lang="en-US"/>
           </a:p>
@@ -10571,7 +10570,7 @@
           <a:p>
             <a:fld id="{3C5E3940-567D-0E4A-B27A-538E5CA3F251}" type="datetimeFigureOut">
               <a:rPr lang="en-US" smtClean="0"/>
-              <a:t>06/03/2026</a:t>
+              <a:t>06/04/2026</a:t>
             </a:fld>
             <a:endParaRPr lang="en-US"/>
           </a:p>
@@ -10779,7 +10778,7 @@
           <a:p>
             <a:fld id="{3C5E3940-567D-0E4A-B27A-538E5CA3F251}" type="datetimeFigureOut">
               <a:rPr lang="en-US" smtClean="0"/>
-              <a:t>06/03/2026</a:t>
+              <a:t>06/04/2026</a:t>
             </a:fld>
             <a:endParaRPr lang="en-US"/>
           </a:p>
@@ -10977,7 +10976,7 @@
           <a:p>
             <a:fld id="{3C5E3940-567D-0E4A-B27A-538E5CA3F251}" type="datetimeFigureOut">
               <a:rPr lang="en-US" smtClean="0"/>
-              <a:t>06/03/2026</a:t>
+              <a:t>06/04/2026</a:t>
             </a:fld>
             <a:endParaRPr lang="en-US"/>
           </a:p>
@@ -11252,7 +11251,7 @@
           <a:p>
             <a:fld id="{3C5E3940-567D-0E4A-B27A-538E5CA3F251}" type="datetimeFigureOut">
               <a:rPr lang="en-US" smtClean="0"/>
-              <a:t>06/03/2026</a:t>
+              <a:t>06/04/2026</a:t>
             </a:fld>
             <a:endParaRPr lang="en-US"/>
           </a:p>
@@ -11517,7 +11516,7 @@
           <a:p>
             <a:fld id="{3C5E3940-567D-0E4A-B27A-538E5CA3F251}" type="datetimeFigureOut">
               <a:rPr lang="en-US" smtClean="0"/>
-              <a:t>06/03/2026</a:t>
+              <a:t>06/04/2026</a:t>
             </a:fld>
             <a:endParaRPr lang="en-US"/>
           </a:p>
@@ -11929,7 +11928,7 @@
           <a:p>
             <a:fld id="{3C5E3940-567D-0E4A-B27A-538E5CA3F251}" type="datetimeFigureOut">
               <a:rPr lang="en-US" smtClean="0"/>
-              <a:t>06/03/2026</a:t>
+              <a:t>06/04/2026</a:t>
             </a:fld>
             <a:endParaRPr lang="en-US"/>
           </a:p>
@@ -12070,7 +12069,7 @@
           <a:p>
             <a:fld id="{3C5E3940-567D-0E4A-B27A-538E5CA3F251}" type="datetimeFigureOut">
               <a:rPr lang="en-US" smtClean="0"/>
-              <a:t>06/03/2026</a:t>
+              <a:t>06/04/2026</a:t>
             </a:fld>
             <a:endParaRPr lang="en-US"/>
           </a:p>
@@ -12183,7 +12182,7 @@
           <a:p>
             <a:fld id="{3C5E3940-567D-0E4A-B27A-538E5CA3F251}" type="datetimeFigureOut">
               <a:rPr lang="en-US" smtClean="0"/>
-              <a:t>06/03/2026</a:t>
+              <a:t>06/04/2026</a:t>
             </a:fld>
             <a:endParaRPr lang="en-US"/>
           </a:p>
@@ -12494,7 +12493,7 @@
           <a:p>
             <a:fld id="{3C5E3940-567D-0E4A-B27A-538E5CA3F251}" type="datetimeFigureOut">
               <a:rPr lang="en-US" smtClean="0"/>
-              <a:t>06/03/2026</a:t>
+              <a:t>06/04/2026</a:t>
             </a:fld>
             <a:endParaRPr lang="en-US"/>
           </a:p>
@@ -12782,7 +12781,7 @@
           <a:p>
             <a:fld id="{3C5E3940-567D-0E4A-B27A-538E5CA3F251}" type="datetimeFigureOut">
               <a:rPr lang="en-US" smtClean="0"/>
-              <a:t>06/03/2026</a:t>
+              <a:t>06/04/2026</a:t>
             </a:fld>
             <a:endParaRPr lang="en-US"/>
           </a:p>
@@ -13023,7 +13022,7 @@
           <a:p>
             <a:fld id="{3C5E3940-567D-0E4A-B27A-538E5CA3F251}" type="datetimeFigureOut">
               <a:rPr lang="en-US" smtClean="0"/>
-              <a:t>06/03/2026</a:t>
+              <a:t>06/04/2026</a:t>
             </a:fld>
             <a:endParaRPr lang="en-US"/>
           </a:p>
@@ -14243,7 +14242,7 @@
           <p:nvPr/>
         </p:nvPicPr>
         <p:blipFill>
-          <a:blip r:embed="rId2"/>
+          <a:blip r:embed="rId4"/>
           <a:stretch>
             <a:fillRect/>
           </a:stretch>
@@ -14252,6 +14251,43 @@
           <a:xfrm>
             <a:off x="6525453" y="1544873"/>
             <a:ext cx="5666547" cy="3768253"/>
+          </a:xfrm>
+          <a:prstGeom prst="rect">
+            <a:avLst/>
+          </a:prstGeom>
+        </p:spPr>
+      </p:pic>
+      <p:pic>
+        <p:nvPicPr>
+          <p:cNvPr id="11" name="Audio 10">
+            <a:extLst>
+              <a:ext uri="{FF2B5EF4-FFF2-40B4-BE49-F238E27FC236}">
+                <a16:creationId xmlns:a16="http://schemas.microsoft.com/office/drawing/2014/main" id="{1250E00B-4067-D990-7F90-638CF410CD38}"/>
+              </a:ext>
+            </a:extLst>
+          </p:cNvPr>
+          <p:cNvPicPr>
+            <a:picLocks noChangeAspect="1"/>
+          </p:cNvPicPr>
+          <p:nvPr>
+            <a:audioFile r:link="rId2"/>
+            <p:extLst>
+              <p:ext uri="{DAA4B4D4-6D71-4841-9C94-3DE7FCFB9230}">
+                <p14:media xmlns:p14="http://schemas.microsoft.com/office/powerpoint/2010/main" r:embed="rId1"/>
+              </p:ext>
+            </p:extLst>
+          </p:nvPr>
+        </p:nvPicPr>
+        <p:blipFill>
+          <a:blip r:embed="rId5"/>
+          <a:stretch>
+            <a:fillRect/>
+          </a:stretch>
+        </p:blipFill>
+        <p:spPr>
+          <a:xfrm>
+            <a:off x="11226800" y="5892800"/>
+            <a:ext cx="812800" cy="812800"/>
           </a:xfrm>
           <a:prstGeom prst="rect">
             <a:avLst/>
@@ -14268,6 +14304,101 @@
   <p:clrMapOvr>
     <a:masterClrMapping/>
   </p:clrMapOvr>
+  <mc:AlternateContent xmlns:mc="http://schemas.openxmlformats.org/markup-compatibility/2006" xmlns:p14="http://schemas.microsoft.com/office/powerpoint/2010/main">
+    <mc:Choice Requires="p14">
+      <p:transition spd="slow" p14:dur="2000" advTm="160064"/>
+    </mc:Choice>
+    <mc:Fallback xmlns="">
+      <p:transition spd="slow" advTm="160064"/>
+    </mc:Fallback>
+  </mc:AlternateContent>
+  <p:timing>
+    <p:tnLst>
+      <p:par>
+        <p:cTn id="1" dur="indefinite" restart="never" nodeType="tmRoot">
+          <p:childTnLst>
+            <p:seq concurrent="1" nextAc="seek">
+              <p:cTn id="2" dur="indefinite" nodeType="mainSeq">
+                <p:childTnLst>
+                  <p:par>
+                    <p:cTn id="3" fill="hold">
+                      <p:stCondLst>
+                        <p:cond delay="indefinite"/>
+                        <p:cond evt="onBegin" delay="0">
+                          <p:tn val="2"/>
+                        </p:cond>
+                      </p:stCondLst>
+                      <p:childTnLst>
+                        <p:par>
+                          <p:cTn id="4" fill="hold">
+                            <p:stCondLst>
+                              <p:cond delay="0"/>
+                            </p:stCondLst>
+                            <p:childTnLst>
+                              <p:par>
+                                <p:cTn id="5" presetID="1" presetClass="mediacall" presetSubtype="0" fill="hold" nodeType="afterEffect">
+                                  <p:stCondLst>
+                                    <p:cond delay="0"/>
+                                  </p:stCondLst>
+                                  <p:childTnLst>
+                                    <p:cmd type="call" cmd="playFrom(0.0)">
+                                      <p:cBhvr>
+                                        <p:cTn id="6" dur="1" fill="hold"/>
+                                        <p:tgtEl>
+                                          <p:spTgt spid="11"/>
+                                        </p:tgtEl>
+                                      </p:cBhvr>
+                                    </p:cmd>
+                                  </p:childTnLst>
+                                </p:cTn>
+                              </p:par>
+                            </p:childTnLst>
+                          </p:cTn>
+                        </p:par>
+                      </p:childTnLst>
+                    </p:cTn>
+                  </p:par>
+                </p:childTnLst>
+              </p:cTn>
+              <p:prevCondLst>
+                <p:cond evt="onPrev" delay="0">
+                  <p:tgtEl>
+                    <p:sldTgt/>
+                  </p:tgtEl>
+                </p:cond>
+              </p:prevCondLst>
+              <p:nextCondLst>
+                <p:cond evt="onNext" delay="0">
+                  <p:tgtEl>
+                    <p:sldTgt/>
+                  </p:tgtEl>
+                </p:cond>
+              </p:nextCondLst>
+            </p:seq>
+            <p:audio isNarration="1">
+              <p:cMediaNode vol="80000" showWhenStopped="0">
+                <p:cTn id="7" fill="hold" display="0">
+                  <p:stCondLst>
+                    <p:cond delay="indefinite"/>
+                  </p:stCondLst>
+                  <p:endCondLst>
+                    <p:cond evt="onStopAudio" delay="0">
+                      <p:tgtEl>
+                        <p:sldTgt/>
+                      </p:tgtEl>
+                    </p:cond>
+                  </p:endCondLst>
+                </p:cTn>
+                <p:tgtEl>
+                  <p:spTgt spid="11"/>
+                </p:tgtEl>
+              </p:cMediaNode>
+            </p:audio>
+          </p:childTnLst>
+        </p:cTn>
+      </p:par>
+    </p:tnLst>
+  </p:timing>
 </p:sld>
 </file>
 
@@ -14536,10 +14667,47 @@
         </p:xfrm>
         <a:graphic>
           <a:graphicData uri="http://schemas.openxmlformats.org/drawingml/2006/diagram">
-            <dgm:relIds xmlns:dgm="http://schemas.openxmlformats.org/drawingml/2006/diagram" xmlns:r="http://schemas.openxmlformats.org/officeDocument/2006/relationships" r:dm="rId2" r:lo="rId3" r:qs="rId4" r:cs="rId5"/>
+            <dgm:relIds xmlns:dgm="http://schemas.openxmlformats.org/drawingml/2006/diagram" xmlns:r="http://schemas.openxmlformats.org/officeDocument/2006/relationships" r:dm="rId4" r:lo="rId5" r:qs="rId6" r:cs="rId7"/>
           </a:graphicData>
         </a:graphic>
       </p:graphicFrame>
+      <p:pic>
+        <p:nvPicPr>
+          <p:cNvPr id="14" name="Audio 13">
+            <a:extLst>
+              <a:ext uri="{FF2B5EF4-FFF2-40B4-BE49-F238E27FC236}">
+                <a16:creationId xmlns:a16="http://schemas.microsoft.com/office/drawing/2014/main" id="{20915839-02E0-F93F-D781-C003AF1F6075}"/>
+              </a:ext>
+            </a:extLst>
+          </p:cNvPr>
+          <p:cNvPicPr>
+            <a:picLocks noChangeAspect="1"/>
+          </p:cNvPicPr>
+          <p:nvPr>
+            <a:audioFile r:link="rId2"/>
+            <p:extLst>
+              <p:ext uri="{DAA4B4D4-6D71-4841-9C94-3DE7FCFB9230}">
+                <p14:media xmlns:p14="http://schemas.microsoft.com/office/powerpoint/2010/main" r:embed="rId1"/>
+              </p:ext>
+            </p:extLst>
+          </p:nvPr>
+        </p:nvPicPr>
+        <p:blipFill>
+          <a:blip r:embed="rId9"/>
+          <a:stretch>
+            <a:fillRect/>
+          </a:stretch>
+        </p:blipFill>
+        <p:spPr>
+          <a:xfrm>
+            <a:off x="11226800" y="5892800"/>
+            <a:ext cx="812800" cy="812800"/>
+          </a:xfrm>
+          <a:prstGeom prst="rect">
+            <a:avLst/>
+          </a:prstGeom>
+        </p:spPr>
+      </p:pic>
     </p:spTree>
     <p:extLst>
       <p:ext uri="{BB962C8B-B14F-4D97-AF65-F5344CB8AC3E}">
@@ -14550,6 +14718,101 @@
   <p:clrMapOvr>
     <a:masterClrMapping/>
   </p:clrMapOvr>
+  <mc:AlternateContent xmlns:mc="http://schemas.openxmlformats.org/markup-compatibility/2006" xmlns:p14="http://schemas.microsoft.com/office/powerpoint/2010/main">
+    <mc:Choice Requires="p14">
+      <p:transition spd="slow" p14:dur="2000" advTm="54881"/>
+    </mc:Choice>
+    <mc:Fallback xmlns="">
+      <p:transition spd="slow" advTm="54881"/>
+    </mc:Fallback>
+  </mc:AlternateContent>
+  <p:timing>
+    <p:tnLst>
+      <p:par>
+        <p:cTn id="1" dur="indefinite" restart="never" nodeType="tmRoot">
+          <p:childTnLst>
+            <p:seq concurrent="1" nextAc="seek">
+              <p:cTn id="2" dur="indefinite" nodeType="mainSeq">
+                <p:childTnLst>
+                  <p:par>
+                    <p:cTn id="3" fill="hold">
+                      <p:stCondLst>
+                        <p:cond delay="indefinite"/>
+                        <p:cond evt="onBegin" delay="0">
+                          <p:tn val="2"/>
+                        </p:cond>
+                      </p:stCondLst>
+                      <p:childTnLst>
+                        <p:par>
+                          <p:cTn id="4" fill="hold">
+                            <p:stCondLst>
+                              <p:cond delay="0"/>
+                            </p:stCondLst>
+                            <p:childTnLst>
+                              <p:par>
+                                <p:cTn id="5" presetID="1" presetClass="mediacall" presetSubtype="0" fill="hold" nodeType="afterEffect">
+                                  <p:stCondLst>
+                                    <p:cond delay="0"/>
+                                  </p:stCondLst>
+                                  <p:childTnLst>
+                                    <p:cmd type="call" cmd="playFrom(0.0)">
+                                      <p:cBhvr>
+                                        <p:cTn id="6" dur="1" fill="hold"/>
+                                        <p:tgtEl>
+                                          <p:spTgt spid="14"/>
+                                        </p:tgtEl>
+                                      </p:cBhvr>
+                                    </p:cmd>
+                                  </p:childTnLst>
+                                </p:cTn>
+                              </p:par>
+                            </p:childTnLst>
+                          </p:cTn>
+                        </p:par>
+                      </p:childTnLst>
+                    </p:cTn>
+                  </p:par>
+                </p:childTnLst>
+              </p:cTn>
+              <p:prevCondLst>
+                <p:cond evt="onPrev" delay="0">
+                  <p:tgtEl>
+                    <p:sldTgt/>
+                  </p:tgtEl>
+                </p:cond>
+              </p:prevCondLst>
+              <p:nextCondLst>
+                <p:cond evt="onNext" delay="0">
+                  <p:tgtEl>
+                    <p:sldTgt/>
+                  </p:tgtEl>
+                </p:cond>
+              </p:nextCondLst>
+            </p:seq>
+            <p:audio isNarration="1">
+              <p:cMediaNode vol="80000" showWhenStopped="0">
+                <p:cTn id="7" fill="hold" display="0">
+                  <p:stCondLst>
+                    <p:cond delay="indefinite"/>
+                  </p:stCondLst>
+                  <p:endCondLst>
+                    <p:cond evt="onStopAudio" delay="0">
+                      <p:tgtEl>
+                        <p:sldTgt/>
+                      </p:tgtEl>
+                    </p:cond>
+                  </p:endCondLst>
+                </p:cTn>
+                <p:tgtEl>
+                  <p:spTgt spid="14"/>
+                </p:tgtEl>
+              </p:cMediaNode>
+            </p:audio>
+          </p:childTnLst>
+        </p:cTn>
+      </p:par>
+    </p:tnLst>
+  </p:timing>
 </p:sld>
 </file>
 
@@ -14796,6 +15059,43 @@
           </a:fontRef>
         </p:style>
       </p:cxnSp>
+      <p:pic>
+        <p:nvPicPr>
+          <p:cNvPr id="6" name="Audio 5">
+            <a:extLst>
+              <a:ext uri="{FF2B5EF4-FFF2-40B4-BE49-F238E27FC236}">
+                <a16:creationId xmlns:a16="http://schemas.microsoft.com/office/drawing/2014/main" id="{11634080-A720-622C-8E7B-D2C740C11CBE}"/>
+              </a:ext>
+            </a:extLst>
+          </p:cNvPr>
+          <p:cNvPicPr>
+            <a:picLocks noChangeAspect="1"/>
+          </p:cNvPicPr>
+          <p:nvPr>
+            <a:audioFile r:link="rId2"/>
+            <p:extLst>
+              <p:ext uri="{DAA4B4D4-6D71-4841-9C94-3DE7FCFB9230}">
+                <p14:media xmlns:p14="http://schemas.microsoft.com/office/powerpoint/2010/main" r:embed="rId1"/>
+              </p:ext>
+            </p:extLst>
+          </p:nvPr>
+        </p:nvPicPr>
+        <p:blipFill>
+          <a:blip r:embed="rId4"/>
+          <a:stretch>
+            <a:fillRect/>
+          </a:stretch>
+        </p:blipFill>
+        <p:spPr>
+          <a:xfrm>
+            <a:off x="11226800" y="5892800"/>
+            <a:ext cx="812800" cy="812800"/>
+          </a:xfrm>
+          <a:prstGeom prst="rect">
+            <a:avLst/>
+          </a:prstGeom>
+        </p:spPr>
+      </p:pic>
     </p:spTree>
     <p:extLst>
       <p:ext uri="{BB962C8B-B14F-4D97-AF65-F5344CB8AC3E}">
@@ -14806,6 +15106,101 @@
   <p:clrMapOvr>
     <a:masterClrMapping/>
   </p:clrMapOvr>
+  <mc:AlternateContent xmlns:mc="http://schemas.openxmlformats.org/markup-compatibility/2006" xmlns:p14="http://schemas.microsoft.com/office/powerpoint/2010/main">
+    <mc:Choice Requires="p14">
+      <p:transition spd="slow" p14:dur="2000" advTm="47168"/>
+    </mc:Choice>
+    <mc:Fallback xmlns="">
+      <p:transition spd="slow" advTm="47168"/>
+    </mc:Fallback>
+  </mc:AlternateContent>
+  <p:timing>
+    <p:tnLst>
+      <p:par>
+        <p:cTn id="1" dur="indefinite" restart="never" nodeType="tmRoot">
+          <p:childTnLst>
+            <p:seq concurrent="1" nextAc="seek">
+              <p:cTn id="2" dur="indefinite" nodeType="mainSeq">
+                <p:childTnLst>
+                  <p:par>
+                    <p:cTn id="3" fill="hold">
+                      <p:stCondLst>
+                        <p:cond delay="indefinite"/>
+                        <p:cond evt="onBegin" delay="0">
+                          <p:tn val="2"/>
+                        </p:cond>
+                      </p:stCondLst>
+                      <p:childTnLst>
+                        <p:par>
+                          <p:cTn id="4" fill="hold">
+                            <p:stCondLst>
+                              <p:cond delay="0"/>
+                            </p:stCondLst>
+                            <p:childTnLst>
+                              <p:par>
+                                <p:cTn id="5" presetID="1" presetClass="mediacall" presetSubtype="0" fill="hold" nodeType="afterEffect">
+                                  <p:stCondLst>
+                                    <p:cond delay="0"/>
+                                  </p:stCondLst>
+                                  <p:childTnLst>
+                                    <p:cmd type="call" cmd="playFrom(0.0)">
+                                      <p:cBhvr>
+                                        <p:cTn id="6" dur="1" fill="hold"/>
+                                        <p:tgtEl>
+                                          <p:spTgt spid="6"/>
+                                        </p:tgtEl>
+                                      </p:cBhvr>
+                                    </p:cmd>
+                                  </p:childTnLst>
+                                </p:cTn>
+                              </p:par>
+                            </p:childTnLst>
+                          </p:cTn>
+                        </p:par>
+                      </p:childTnLst>
+                    </p:cTn>
+                  </p:par>
+                </p:childTnLst>
+              </p:cTn>
+              <p:prevCondLst>
+                <p:cond evt="onPrev" delay="0">
+                  <p:tgtEl>
+                    <p:sldTgt/>
+                  </p:tgtEl>
+                </p:cond>
+              </p:prevCondLst>
+              <p:nextCondLst>
+                <p:cond evt="onNext" delay="0">
+                  <p:tgtEl>
+                    <p:sldTgt/>
+                  </p:tgtEl>
+                </p:cond>
+              </p:nextCondLst>
+            </p:seq>
+            <p:audio isNarration="1">
+              <p:cMediaNode vol="80000" showWhenStopped="0">
+                <p:cTn id="7" fill="hold" display="0">
+                  <p:stCondLst>
+                    <p:cond delay="indefinite"/>
+                  </p:stCondLst>
+                  <p:endCondLst>
+                    <p:cond evt="onStopAudio" delay="0">
+                      <p:tgtEl>
+                        <p:sldTgt/>
+                      </p:tgtEl>
+                    </p:cond>
+                  </p:endCondLst>
+                </p:cTn>
+                <p:tgtEl>
+                  <p:spTgt spid="6"/>
+                </p:tgtEl>
+              </p:cMediaNode>
+            </p:audio>
+          </p:childTnLst>
+        </p:cTn>
+      </p:par>
+    </p:tnLst>
+  </p:timing>
 </p:sld>
 </file>
 
@@ -16545,7 +16940,7 @@
                   <a:schemeClr val="bg1"/>
                 </a:solidFill>
               </a:rPr>
-              <a:t>Telemetry and race performance data from 2023 Formula 1’s </a:t>
+              <a:t>Telemetry and race performance data from 2023-2025 Formula 1’s </a:t>
             </a:r>
             <a:r>
               <a:rPr lang="en-US" sz="2000" b="1" dirty="0">
@@ -20095,10 +20490,47 @@
         </p:xfrm>
         <a:graphic>
           <a:graphicData uri="http://schemas.openxmlformats.org/drawingml/2006/diagram">
-            <dgm:relIds xmlns:dgm="http://schemas.openxmlformats.org/drawingml/2006/diagram" xmlns:r="http://schemas.openxmlformats.org/officeDocument/2006/relationships" r:dm="rId2" r:lo="rId3" r:qs="rId4" r:cs="rId5"/>
+            <dgm:relIds xmlns:dgm="http://schemas.openxmlformats.org/drawingml/2006/diagram" xmlns:r="http://schemas.openxmlformats.org/officeDocument/2006/relationships" r:dm="rId4" r:lo="rId5" r:qs="rId6" r:cs="rId7"/>
           </a:graphicData>
         </a:graphic>
       </p:graphicFrame>
+      <p:pic>
+        <p:nvPicPr>
+          <p:cNvPr id="48" name="Audio 47">
+            <a:extLst>
+              <a:ext uri="{FF2B5EF4-FFF2-40B4-BE49-F238E27FC236}">
+                <a16:creationId xmlns:a16="http://schemas.microsoft.com/office/drawing/2014/main" id="{D61F1B5D-A794-B5B1-9972-FD9FBAE891A2}"/>
+              </a:ext>
+            </a:extLst>
+          </p:cNvPr>
+          <p:cNvPicPr>
+            <a:picLocks noChangeAspect="1"/>
+          </p:cNvPicPr>
+          <p:nvPr>
+            <a:audioFile r:link="rId2"/>
+            <p:extLst>
+              <p:ext uri="{DAA4B4D4-6D71-4841-9C94-3DE7FCFB9230}">
+                <p14:media xmlns:p14="http://schemas.microsoft.com/office/powerpoint/2010/main" r:embed="rId1"/>
+              </p:ext>
+            </p:extLst>
+          </p:nvPr>
+        </p:nvPicPr>
+        <p:blipFill>
+          <a:blip r:embed="rId9"/>
+          <a:stretch>
+            <a:fillRect/>
+          </a:stretch>
+        </p:blipFill>
+        <p:spPr>
+          <a:xfrm>
+            <a:off x="11226800" y="5892800"/>
+            <a:ext cx="812800" cy="812800"/>
+          </a:xfrm>
+          <a:prstGeom prst="rect">
+            <a:avLst/>
+          </a:prstGeom>
+        </p:spPr>
+      </p:pic>
     </p:spTree>
     <p:extLst>
       <p:ext uri="{BB962C8B-B14F-4D97-AF65-F5344CB8AC3E}">
@@ -20109,6 +20541,101 @@
   <p:clrMapOvr>
     <a:masterClrMapping/>
   </p:clrMapOvr>
+  <mc:AlternateContent xmlns:mc="http://schemas.openxmlformats.org/markup-compatibility/2006" xmlns:p14="http://schemas.microsoft.com/office/powerpoint/2010/main">
+    <mc:Choice Requires="p14">
+      <p:transition spd="slow" p14:dur="2000" advTm="87393"/>
+    </mc:Choice>
+    <mc:Fallback xmlns="">
+      <p:transition spd="slow" advTm="87393"/>
+    </mc:Fallback>
+  </mc:AlternateContent>
+  <p:timing>
+    <p:tnLst>
+      <p:par>
+        <p:cTn id="1" dur="indefinite" restart="never" nodeType="tmRoot">
+          <p:childTnLst>
+            <p:seq concurrent="1" nextAc="seek">
+              <p:cTn id="2" dur="indefinite" nodeType="mainSeq">
+                <p:childTnLst>
+                  <p:par>
+                    <p:cTn id="3" fill="hold">
+                      <p:stCondLst>
+                        <p:cond delay="indefinite"/>
+                        <p:cond evt="onBegin" delay="0">
+                          <p:tn val="2"/>
+                        </p:cond>
+                      </p:stCondLst>
+                      <p:childTnLst>
+                        <p:par>
+                          <p:cTn id="4" fill="hold">
+                            <p:stCondLst>
+                              <p:cond delay="0"/>
+                            </p:stCondLst>
+                            <p:childTnLst>
+                              <p:par>
+                                <p:cTn id="5" presetID="1" presetClass="mediacall" presetSubtype="0" fill="hold" nodeType="afterEffect">
+                                  <p:stCondLst>
+                                    <p:cond delay="0"/>
+                                  </p:stCondLst>
+                                  <p:childTnLst>
+                                    <p:cmd type="call" cmd="playFrom(0.0)">
+                                      <p:cBhvr>
+                                        <p:cTn id="6" dur="1" fill="hold"/>
+                                        <p:tgtEl>
+                                          <p:spTgt spid="48"/>
+                                        </p:tgtEl>
+                                      </p:cBhvr>
+                                    </p:cmd>
+                                  </p:childTnLst>
+                                </p:cTn>
+                              </p:par>
+                            </p:childTnLst>
+                          </p:cTn>
+                        </p:par>
+                      </p:childTnLst>
+                    </p:cTn>
+                  </p:par>
+                </p:childTnLst>
+              </p:cTn>
+              <p:prevCondLst>
+                <p:cond evt="onPrev" delay="0">
+                  <p:tgtEl>
+                    <p:sldTgt/>
+                  </p:tgtEl>
+                </p:cond>
+              </p:prevCondLst>
+              <p:nextCondLst>
+                <p:cond evt="onNext" delay="0">
+                  <p:tgtEl>
+                    <p:sldTgt/>
+                  </p:tgtEl>
+                </p:cond>
+              </p:nextCondLst>
+            </p:seq>
+            <p:audio isNarration="1">
+              <p:cMediaNode vol="80000" showWhenStopped="0">
+                <p:cTn id="7" fill="hold" display="0">
+                  <p:stCondLst>
+                    <p:cond delay="indefinite"/>
+                  </p:stCondLst>
+                  <p:endCondLst>
+                    <p:cond evt="onStopAudio" delay="0">
+                      <p:tgtEl>
+                        <p:sldTgt/>
+                      </p:tgtEl>
+                    </p:cond>
+                  </p:endCondLst>
+                </p:cTn>
+                <p:tgtEl>
+                  <p:spTgt spid="48"/>
+                </p:tgtEl>
+              </p:cMediaNode>
+            </p:audio>
+          </p:childTnLst>
+        </p:cTn>
+      </p:par>
+    </p:tnLst>
+  </p:timing>
 </p:sld>
 </file>
 
@@ -20743,6 +21270,21 @@
 </file>
 
 <file path=customXml/item1.xml><?xml version="1.0" encoding="utf-8"?>
+<p:properties xmlns:p="http://schemas.microsoft.com/office/2006/metadata/properties" xmlns:xsi="http://www.w3.org/2001/XMLSchema-instance" xmlns:pc="http://schemas.microsoft.com/office/infopath/2007/PartnerControls">
+  <documentManagement/>
+</p:properties>
+</file>
+
+<file path=customXml/item2.xml><?xml version="1.0" encoding="utf-8"?>
+<?mso-contentType ?>
+<FormTemplates xmlns="http://schemas.microsoft.com/sharepoint/v3/contenttype/forms">
+  <Display>DocumentLibraryForm</Display>
+  <Edit>DocumentLibraryForm</Edit>
+  <New>DocumentLibraryForm</New>
+</FormTemplates>
+</file>
+
+<file path=customXml/item3.xml><?xml version="1.0" encoding="utf-8"?>
 <ct:contentTypeSchema xmlns:ct="http://schemas.microsoft.com/office/2006/metadata/contentType" xmlns:ma="http://schemas.microsoft.com/office/2006/metadata/properties/metaAttributes" ct:_="" ma:_="" ma:contentTypeName="Document" ma:contentTypeID="0x0101001977F4A02A317C42B024828369745087" ma:contentTypeVersion="1" ma:contentTypeDescription="Create a new document." ma:contentTypeScope="" ma:versionID="c4dd34d2f253302d809d0638651758a5">
   <xsd:schema xmlns:xsd="http://www.w3.org/2001/XMLSchema" xmlns:xs="http://www.w3.org/2001/XMLSchema" xmlns:p="http://schemas.microsoft.com/office/2006/metadata/properties" xmlns:ns3="19149eaa-78a7-4c13-bd81-fa7ad81bba69" targetNamespace="http://schemas.microsoft.com/office/2006/metadata/properties" ma:root="true" ma:fieldsID="b1f8b89e39192d90fca2f9d2c18adb86" ns3:_="">
     <xsd:import namespace="19149eaa-78a7-4c13-bd81-fa7ad81bba69"/>
@@ -20868,22 +21410,31 @@
 </ct:contentTypeSchema>
 </file>
 
-<file path=customXml/item2.xml><?xml version="1.0" encoding="utf-8"?>
-<?mso-contentType ?>
-<FormTemplates xmlns="http://schemas.microsoft.com/sharepoint/v3/contenttype/forms">
-  <Display>DocumentLibraryForm</Display>
-  <Edit>DocumentLibraryForm</Edit>
-  <New>DocumentLibraryForm</New>
-</FormTemplates>
+<file path=customXml/itemProps1.xml><?xml version="1.0" encoding="utf-8"?>
+<ds:datastoreItem xmlns:ds="http://schemas.openxmlformats.org/officeDocument/2006/customXml" ds:itemID="{4022A0F6-B6FD-4379-AC99-1FBF977FED2B}">
+  <ds:schemaRefs>
+    <ds:schemaRef ds:uri="http://purl.org/dc/elements/1.1/"/>
+    <ds:schemaRef ds:uri="http://schemas.microsoft.com/office/2006/metadata/properties"/>
+    <ds:schemaRef ds:uri="http://purl.org/dc/dcmitype/"/>
+    <ds:schemaRef ds:uri="http://purl.org/dc/terms/"/>
+    <ds:schemaRef ds:uri="http://www.w3.org/XML/1998/namespace"/>
+    <ds:schemaRef ds:uri="http://schemas.microsoft.com/office/2006/documentManagement/types"/>
+    <ds:schemaRef ds:uri="http://schemas.microsoft.com/office/infopath/2007/PartnerControls"/>
+    <ds:schemaRef ds:uri="http://schemas.openxmlformats.org/package/2006/metadata/core-properties"/>
+    <ds:schemaRef ds:uri="19149eaa-78a7-4c13-bd81-fa7ad81bba69"/>
+  </ds:schemaRefs>
+</ds:datastoreItem>
 </file>
 
-<file path=customXml/item3.xml><?xml version="1.0" encoding="utf-8"?>
-<p:properties xmlns:p="http://schemas.microsoft.com/office/2006/metadata/properties" xmlns:xsi="http://www.w3.org/2001/XMLSchema-instance" xmlns:pc="http://schemas.microsoft.com/office/infopath/2007/PartnerControls">
-  <documentManagement/>
-</p:properties>
+<file path=customXml/itemProps2.xml><?xml version="1.0" encoding="utf-8"?>
+<ds:datastoreItem xmlns:ds="http://schemas.openxmlformats.org/officeDocument/2006/customXml" ds:itemID="{D43A19D8-B8BC-41EF-B29F-C5418F08156C}">
+  <ds:schemaRefs>
+    <ds:schemaRef ds:uri="http://schemas.microsoft.com/sharepoint/v3/contenttype/forms"/>
+  </ds:schemaRefs>
+</ds:datastoreItem>
 </file>
 
-<file path=customXml/itemProps1.xml><?xml version="1.0" encoding="utf-8"?>
+<file path=customXml/itemProps3.xml><?xml version="1.0" encoding="utf-8"?>
 <ds:datastoreItem xmlns:ds="http://schemas.openxmlformats.org/officeDocument/2006/customXml" ds:itemID="{0D815BB1-DFC0-4E1E-9A9F-1CA2AA9A35AB}">
   <ds:schemaRefs>
     <ds:schemaRef ds:uri="http://schemas.microsoft.com/office/2006/metadata/contentType"/>
@@ -20899,28 +21450,4 @@
     <ds:schemaRef ds:uri="http://schemas.microsoft.com/internal/obd"/>
   </ds:schemaRefs>
 </ds:datastoreItem>
-</file>
-
-<file path=customXml/itemProps2.xml><?xml version="1.0" encoding="utf-8"?>
-<ds:datastoreItem xmlns:ds="http://schemas.openxmlformats.org/officeDocument/2006/customXml" ds:itemID="{D43A19D8-B8BC-41EF-B29F-C5418F08156C}">
-  <ds:schemaRefs>
-    <ds:schemaRef ds:uri="http://schemas.microsoft.com/sharepoint/v3/contenttype/forms"/>
-  </ds:schemaRefs>
-</ds:datastoreItem>
-</file>
-
-<file path=customXml/itemProps3.xml><?xml version="1.0" encoding="utf-8"?>
-<ds:datastoreItem xmlns:ds="http://schemas.openxmlformats.org/officeDocument/2006/customXml" ds:itemID="{4022A0F6-B6FD-4379-AC99-1FBF977FED2B}">
-  <ds:schemaRefs>
-    <ds:schemaRef ds:uri="http://purl.org/dc/elements/1.1/"/>
-    <ds:schemaRef ds:uri="http://schemas.microsoft.com/office/2006/metadata/properties"/>
-    <ds:schemaRef ds:uri="http://purl.org/dc/dcmitype/"/>
-    <ds:schemaRef ds:uri="http://purl.org/dc/terms/"/>
-    <ds:schemaRef ds:uri="http://www.w3.org/XML/1998/namespace"/>
-    <ds:schemaRef ds:uri="http://schemas.microsoft.com/office/2006/documentManagement/types"/>
-    <ds:schemaRef ds:uri="http://schemas.microsoft.com/office/infopath/2007/PartnerControls"/>
-    <ds:schemaRef ds:uri="http://schemas.openxmlformats.org/package/2006/metadata/core-properties"/>
-    <ds:schemaRef ds:uri="19149eaa-78a7-4c13-bd81-fa7ad81bba69"/>
-  </ds:schemaRefs>
-</ds:datastoreItem>
 </file>
</xml_diff>